<commit_message>
Title the second diagram as Requisition to Payment
Show case 2 through the contract and case 1 straight from the requisition to the purchase order.

Co-authored-by: aleo25672 <aleo25672@users.noreply.github.com>
</commit_message>
<xml_diff>
--- a/docs/REQUISITION_TO_PAYMENT_ER.pptx
+++ b/docs/REQUISITION_TO_PAYMENT_ER.pptx
@@ -3207,7 +3207,7 @@
                 </a:solidFill>
                 <a:latin typeface="Calibri"/>
               </a:rPr>
-              <a:t>Entity diagram  ·  requisition 10001634  ·  contract 4600000042  ·  PO 4500002148  ·  payment 1500000002</a:t>
+              <a:t>From the requisition to the payment. Case 2 includes a contract: 10001634 → 4600000042 → 4500002148 → 1500000002</a:t>
             </a:r>
           </a:p>
         </p:txBody>
@@ -4966,7 +4966,7 @@
                 </a:solidFill>
                 <a:latin typeface="Calibri"/>
               </a:rPr>
-              <a:t>How the entities connect</a:t>
+              <a:t>Requisition to Payment — sample keys</a:t>
             </a:r>
           </a:p>
         </p:txBody>
@@ -5006,7 +5006,7 @@
                 </a:solidFill>
                 <a:latin typeface="Calibri"/>
               </a:rPr>
-              <a:t>With a contract: requisition 10001634, contract 4600000042, PO 4500002148. A direct requisition skips the contract.</a:t>
+              <a:t>Case 2 includes contract 4600000042. Case 1 has no contract: requisition 10001624 goes straight to PO 4500002147.</a:t>
             </a:r>
           </a:p>
         </p:txBody>
@@ -5115,7 +5115,7 @@
                           </a:solidFill>
                           <a:latin typeface="Calibri"/>
                         </a:rPr>
-                        <a:t>Requisition → contract</a:t>
+                        <a:t>Case 2. Requisition → contract</a:t>
                       </a:r>
                     </a:p>
                   </a:txBody>
@@ -5659,7 +5659,7 @@
                           </a:solidFill>
                           <a:latin typeface="Calibri"/>
                         </a:rPr>
-                        <a:t>Direct requisition → PO</a:t>
+                        <a:t>Case 1. Requisition → PO</a:t>
                       </a:r>
                     </a:p>
                   </a:txBody>
@@ -5681,7 +5681,7 @@
                           </a:solidFill>
                           <a:latin typeface="Calibri"/>
                         </a:rPr>
-                        <a:t>PurchaseRequisition + Item on the PO item</a:t>
+                        <a:t>PurchaseRequisition + Item on the PO item. No contract</a:t>
                       </a:r>
                     </a:p>
                   </a:txBody>
@@ -5727,7 +5727,7 @@
                           </a:solidFill>
                           <a:latin typeface="Calibri"/>
                         </a:rPr>
-                        <a:t>That invoice → payment</a:t>
+                        <a:t>Case 1. Invoice → payment</a:t>
                       </a:r>
                     </a:p>
                   </a:txBody>

</xml_diff>